<commit_message>
Update promo slide for dual-layer acceleration
</commit_message>
<xml_diff>
--- a/docs/ComfyUI-AccelDiff_Promo_EN.pptx
+++ b/docs/ComfyUI-AccelDiff_Promo_EN.pptx
@@ -934,7 +934,7 @@
                 <a:ea typeface="思源黑体 CN Bold" panose="020B0800000000000000" pitchFamily="34" charset="-122"/>
                 <a:cs typeface="Microsoft YaHei UI"/>
               </a:rPr>
-              <a:t>Many</a:t>
+              <a:t>Two</a:t>
             </a:r>
             <a:r>
               <a:rPr lang="zh-CN" altLang="en-US" sz="4350" b="1" dirty="0">
@@ -945,7 +945,7 @@
                 <a:ea typeface="思源黑体 CN Bold" panose="020B0800000000000000" pitchFamily="34" charset="-122"/>
                 <a:cs typeface="Microsoft YaHei UI"/>
               </a:rPr>
-              <a:t> Speedups</a:t>
+              <a:t> Layers</a:t>
             </a:r>
           </a:p>
         </ns0:txBody>
@@ -1030,7 +1030,7 @@
                 <a:ea typeface="Microsoft YaHei UI"/>
                 <a:cs typeface="Microsoft YaHei UI"/>
               </a:rPr>
-              <a:t> acceleration framework</a:t>
+              <a:t> acceleration stack</a:t>
             </a:r>
           </a:p>
         </ns0:txBody>
@@ -1339,7 +1339,7 @@
                   <a:ea typeface="思源黑体 CN Bold" panose="020B0800000000000000" pitchFamily="34" charset="-122"/>
                   <a:cs typeface="Microsoft YaHei UI"/>
                 </a:rPr>
-                <a:t>Pick method + model</a:t>
+                <a:t>Pick sampler + model</a:t>
               </a:r>
             </a:p>
           </ns0:txBody>
@@ -1539,7 +1539,7 @@
                   <a:ea typeface="思源黑体 CN Bold" panose="020B0800000000000000" pitchFamily="34" charset="-122"/>
                   <a:cs typeface="Microsoft YaHei UI"/>
                 </a:rPr>
-                <a:t>Auto-wires inference</a:t>
+                <a:t>Use one or both</a:t>
               </a:r>
             </a:p>
           </ns0:txBody>
@@ -3283,7 +3283,7 @@
                 <a:ea typeface="思源黑体 CN Bold" panose="020B0800000000000000" pitchFamily="34" charset="-122"/>
                 <a:cs typeface="Microsoft YaHei UI"/>
               </a:rPr>
-              <a:t>Now: one unified node</a:t>
+              <a:t>Now: one dual-layer node</a:t>
             </a:r>
             <a:endParaRPr sz="2100" dirty="0">
               <a:solidFill>
@@ -3411,7 +3411,7 @@
                 <a:ea typeface="思源黑体 CN Bold" panose="020B0800000000000000" pitchFamily="34" charset="-122"/>
                 <a:cs typeface="Microsoft YaHei UI"/>
               </a:rPr>
-              <a:t>😊 Choose once. Run directly.</a:t>
+              <a:t>😊 Stack both layers.</a:t>
             </a:r>
           </a:p>
         </ns0:txBody>
@@ -3521,7 +3521,7 @@
                 <a:ea typeface="思源黑体 CN Bold" panose="020B0800000000000000" pitchFamily="34" charset="-122"/>
                 <a:cs typeface="Microsoft YaHei UI"/>
               </a:rPr>
-              <a:t>Acceleration methods</a:t>
+              <a:t>Two acceleration layers</a:t>
             </a:r>
           </a:p>
         </ns0:txBody>
@@ -3698,7 +3698,7 @@
                 <a:ea typeface="思源黑体 CN Bold" panose="020B0800000000000000" pitchFamily="34" charset="-122"/>
                 <a:cs typeface="Microsoft YaHei UI"/>
               </a:rPr>
-              <a:t>Relative</a:t>
+              <a:t>Model-level</a:t>
             </a:r>
             <a:r>
               <a:rPr sz="975" b="0" dirty="0">
@@ -3720,7 +3720,7 @@
                 <a:ea typeface="思源黑体 CN Bold" panose="020B0800000000000000" pitchFamily="34" charset="-122"/>
                 <a:cs typeface="Microsoft YaHei UI"/>
               </a:rPr>
-              <a:t>distance criterion</a:t>
+              <a:t>cache criterion</a:t>
             </a:r>
             <a:endParaRPr sz="975" b="0" dirty="0">
               <a:solidFill>
@@ -3755,7 +3755,7 @@
                 <a:ea typeface="思源黑体 CN Bold" panose="020B0800000000000000" pitchFamily="34" charset="-122"/>
                 <a:cs typeface="Microsoft YaHei UI"/>
               </a:rPr>
-              <a:t>Preserves original coefficients and strategy</a:t>
+              <a:t>Preserves TeaCache logic</a:t>
             </a:r>
             <a:endParaRPr sz="975" b="0" dirty="0">
               <a:solidFill>
@@ -3940,7 +3940,7 @@
                 <a:ea typeface="思源黑体 CN Bold" panose="020B0800000000000000" pitchFamily="34" charset="-122"/>
                 <a:cs typeface="Microsoft YaHei UI"/>
               </a:rPr>
-              <a:t>Feature cache + residual reuse</a:t>
+              <a:t>Sampler-level output reuse</a:t>
             </a:r>
           </a:p>
           <a:p>
@@ -3967,7 +3967,7 @@
                 <a:ea typeface="思源黑体 CN Bold" panose="020B0800000000000000" pitchFamily="34" charset="-122"/>
                 <a:cs typeface="Microsoft YaHei UI"/>
               </a:rPr>
-              <a:t>Preserves original logic</a:t>
+              <a:t>Preserves method logic</a:t>
             </a:r>
           </a:p>
         </ns0:txBody>
@@ -4144,7 +4144,7 @@
                 <a:ea typeface="思源黑体 CN Bold" panose="020B0800000000000000" pitchFamily="34" charset="-122"/>
                 <a:cs typeface="Microsoft YaHei UI"/>
               </a:rPr>
-              <a:t>Magnitude-change criterion</a:t>
+              <a:t>Model-level magnitude cache</a:t>
             </a:r>
           </a:p>
           <a:p>
@@ -4171,7 +4171,7 @@
                 <a:ea typeface="思源黑体 CN Bold" panose="020B0800000000000000" pitchFamily="34" charset="-122"/>
                 <a:cs typeface="Microsoft YaHei UI"/>
               </a:rPr>
-              <a:t>Preserves original logic</a:t>
+              <a:t>Preserves method logic</a:t>
             </a:r>
           </a:p>
         </ns0:txBody>
@@ -4348,7 +4348,7 @@
                 <a:ea typeface="思源黑体 CN Bold" panose="020B0800000000000000" pitchFamily="34" charset="-122"/>
                 <a:cs typeface="Microsoft YaHei UI"/>
               </a:rPr>
-              <a:t>Adaptive step skipping</a:t>
+              <a:t>Sampler-level adaptive skipping</a:t>
             </a:r>
           </a:p>
           <a:p>
@@ -4375,7 +4375,7 @@
                 <a:ea typeface="思源黑体 CN Bold" panose="020B0800000000000000" pitchFamily="34" charset="-122"/>
                 <a:cs typeface="Microsoft YaHei UI"/>
               </a:rPr>
-              <a:t>Preserves original logic</a:t>
+              <a:t>Preserves method logic</a:t>
             </a:r>
           </a:p>
         </ns0:txBody>
@@ -6449,7 +6449,7 @@
                 <a:ea typeface="思源黑体 CN Bold" panose="020B0800000000000000" pitchFamily="34" charset="-122"/>
                 <a:cs typeface="阿里巴巴普惠体 2.0 65 Medium" panose="00020600040101010101" pitchFamily="18" charset="-122"/>
               </a:rPr>
-              <a:t>You Only </a:t>
+              <a:t>Stack Both</a:t>
             </a:r>
           </a:p>
           <a:p>
@@ -6460,7 +6460,7 @@
                 <a:ea typeface="思源黑体 CN Bold" panose="020B0800000000000000" pitchFamily="34" charset="-122"/>
                 <a:cs typeface="阿里巴巴普惠体 2.0 65 Medium" panose="00020600040101010101" pitchFamily="18" charset="-122"/>
               </a:rPr>
-              <a:t>Choose Once</a:t>
+              <a:t>Layers</a:t>
             </a:r>
             <a:endParaRPr lang="zh-CN" altLang="en-US" sz="2400" dirty="0">
               <a:latin typeface="思源黑体 CN Bold" panose="020B0800000000000000" pitchFamily="34" charset="-122"/>
@@ -6670,7 +6670,7 @@
                 <a:ea typeface="思源黑体 CN Bold" panose="020B0800000000000000" pitchFamily="34" charset="-122"/>
                 <a:cs typeface="Microsoft YaHei UI"/>
               </a:rPr>
-              <a:t>Less wiring, more output</a:t>
+              <a:t>Stack sampler-level and model-level methods</a:t>
             </a:r>
           </a:p>
         </ns0:txBody>
@@ -6884,7 +6884,7 @@
                 <a:ea typeface="Microsoft YaHei UI"/>
                 <a:cs typeface="Microsoft YaHei UI"/>
               </a:rPr>
-              <a:t>Less compute, quality intact</a:t>
+              <a:t>Sampler + model speedups</a:t>
             </a:r>
             <a:endParaRPr sz="1600" b="1" dirty="0">
               <a:solidFill>

</xml_diff>